<commit_message>
Improve Streamlit mining simulator
</commit_message>
<xml_diff>
--- a/presentation/Sparrow_Cluster_Profiles.pptx
+++ b/presentation/Sparrow_Cluster_Profiles.pptx
@@ -6052,7 +6052,7 @@
         </p:nvSpPr>
         <p:spPr>
           <a:xfrm>
-            <a:off x="731520" y="5897880"/>
+            <a:off x="731520" y="5715000"/>
             <a:ext cx="10698480" cy="457200"/>
           </a:xfrm>
           <a:prstGeom prst="rect">
@@ -6075,7 +6075,43 @@
               </a:defRPr>
             </a:pPr>
             <a:r>
-              <a:t>Presentation answer: K-means provides interpretable environmental profiles, but the modest silhouette requires cautious interpretation.</a:t>
+              <a:t>K-means provides interpretable environmental profiles, but the modest silhouette requires cautious interpretation.</a:t>
+            </a:r>
+          </a:p>
+        </p:txBody>
+      </p:sp>
+      <p:sp>
+        <p:nvSpPr>
+          <p:cNvPr id="9" name="TextBox 8"/>
+          <p:cNvSpPr txBox="1"/>
+          <p:nvPr/>
+        </p:nvSpPr>
+        <p:spPr>
+          <a:xfrm>
+            <a:off x="731520" y="6144768"/>
+            <a:ext cx="10698480" cy="320040"/>
+          </a:xfrm>
+          <a:prstGeom prst="rect">
+            <a:avLst/>
+          </a:prstGeom>
+          <a:noFill/>
+        </p:spPr>
+        <p:txBody>
+          <a:bodyPr wrap="square" lIns="36576" rIns="36576" tIns="18288" bIns="18288">
+            <a:spAutoFit/>
+          </a:bodyPr>
+          <a:lstStyle/>
+          <a:p>
+            <a:pPr algn="l">
+              <a:defRPr sz="1300" b="1">
+                <a:solidFill>
+                  <a:srgbClr val="1F4A33"/>
+                </a:solidFill>
+                <a:latin typeface="Aptos"/>
+              </a:defRPr>
+            </a:pPr>
+            <a:r>
+              <a:t>Live model lab: https://sparrow-nest-data-mining.streamlit.app</a:t>
             </a:r>
           </a:p>
         </p:txBody>

</xml_diff>